<commit_message>
docs: embed system architecture diagram into PowerPoint slide 3
</commit_message>
<xml_diff>
--- a/assets/AI_Mock_Interview_Platform_Presentation.pptx
+++ b/assets/AI_Mock_Interview_Platform_Presentation.pptx
@@ -3688,7 +3688,7 @@
         <p:spPr>
           <a:xfrm>
             <a:off x="731520" y="1645920"/>
-            <a:ext cx="10698480" cy="4572000"/>
+            <a:ext cx="5303520" cy="4206240"/>
           </a:xfrm>
           <a:prstGeom prst="rect">
             <a:avLst/>
@@ -3703,25 +3703,25 @@
           <a:p>
             <a:pPr>
               <a:spcAft>
-                <a:spcPts val="1800"/>
+                <a:spcPts val="1200"/>
               </a:spcAft>
-              <a:defRPr sz="1500">
-                <a:solidFill>
-                  <a:srgbClr val="F8FAFC"/>
+              <a:defRPr sz="1600" b="1">
+                <a:solidFill>
+                  <a:srgbClr val="6366F1"/>
                 </a:solidFill>
                 <a:latin typeface="Arial"/>
               </a:defRPr>
             </a:pPr>
             <a:r>
-              <a:t>A decoupled, reverse-proxied local architecture running securely under Supervisord:</a:t>
+              <a:t>Architecture &amp; Data Pipeline Flow:</a:t>
             </a:r>
           </a:p>
           <a:p>
             <a:pPr>
               <a:spcAft>
-                <a:spcPts val="1200"/>
+                <a:spcPts val="800"/>
               </a:spcAft>
-              <a:defRPr sz="1400">
+              <a:defRPr sz="1300">
                 <a:solidFill>
                   <a:srgbClr val="94A3B8"/>
                 </a:solidFill>
@@ -3729,15 +3729,15 @@
               </a:defRPr>
             </a:pPr>
             <a:r>
-              <a:t>1. Resume Processing: Documents are parsed via PyMuPDF/zipfile, split by character overlaps, embedded via sentence-transformers, and saved into a local ChromaDB.</a:t>
+              <a:t>•  1. Ingestion: PDF/DOCX resumes are parsed, split, embedded, and cached in local ChromaDB.</a:t>
             </a:r>
           </a:p>
           <a:p>
             <a:pPr>
               <a:spcAft>
-                <a:spcPts val="1200"/>
+                <a:spcPts val="800"/>
               </a:spcAft>
-              <a:defRPr sz="1400">
+              <a:defRPr sz="1300">
                 <a:solidFill>
                   <a:srgbClr val="94A3B8"/>
                 </a:solidFill>
@@ -3745,15 +3745,15 @@
               </a:defRPr>
             </a:pPr>
             <a:r>
-              <a:t>2. Interview Orchestration: FastAPI manages conversation state. It retrieves context from ChromaDB, queries LLM engines (Gemini/Groq), and streams Edge TTS audio.</a:t>
+              <a:t>•  2. Recruiter Persona: FastAPI manages context, fetches semantic blocks, and calls LLM recruiter logic.</a:t>
             </a:r>
           </a:p>
           <a:p>
             <a:pPr>
               <a:spcAft>
-                <a:spcPts val="1200"/>
+                <a:spcPts val="800"/>
               </a:spcAft>
-              <a:defRPr sz="1400">
+              <a:defRPr sz="1300">
                 <a:solidFill>
                   <a:srgbClr val="94A3B8"/>
                 </a:solidFill>
@@ -3761,15 +3761,15 @@
               </a:defRPr>
             </a:pPr>
             <a:r>
-              <a:t>3. Speech Loop: Custom HTML5 Mic Recorder uploads candidate audio to FastAPI, transcribing speech locally using cached in-memory Whisper tiny weights.</a:t>
+              <a:t>•  3. Speech Loop: Converts questions to audio (Edge TTS); candidate speaks and Whisper STT transcribes it locally.</a:t>
             </a:r>
           </a:p>
           <a:p>
             <a:pPr>
               <a:spcAft>
-                <a:spcPts val="1200"/>
+                <a:spcPts val="800"/>
               </a:spcAft>
-              <a:defRPr sz="1400">
+              <a:defRPr sz="1300">
                 <a:solidFill>
                   <a:srgbClr val="94A3B8"/>
                 </a:solidFill>
@@ -3777,7 +3777,7 @@
               </a:defRPr>
             </a:pPr>
             <a:r>
-              <a:t>4. Reverse Proxying: Nginx acts as a unified entrypoint on port 7860, routing HTTP (/api), Static files (/static/audio and /static/reports), and Streamlit WebSockets (/).</a:t>
+              <a:t>•  4. Proxy Integration: Single entrypoint (Nginx) routes Streamlit websockets &amp; FastAPI endpoints securely.</a:t>
             </a:r>
           </a:p>
         </p:txBody>
@@ -3791,7 +3791,7 @@
         <p:spPr>
           <a:xfrm>
             <a:off x="731520" y="4937760"/>
-            <a:ext cx="10698480" cy="1097280"/>
+            <a:ext cx="5303520" cy="1463040"/>
           </a:xfrm>
           <a:prstGeom prst="rect">
             <a:avLst/>
@@ -3806,9 +3806,9 @@
           <a:p>
             <a:pPr>
               <a:spcAft>
-                <a:spcPts val="400"/>
+                <a:spcPts val="800"/>
               </a:spcAft>
-              <a:defRPr sz="1300" b="1">
+              <a:defRPr sz="1100" b="1">
                 <a:solidFill>
                   <a:srgbClr val="2DD4BF"/>
                 </a:solidFill>
@@ -3816,24 +3816,56 @@
               </a:defRPr>
             </a:pPr>
             <a:r>
-              <a:t>DEPLOYMENT LINK: https://huggingface.co/spaces/tejashrichoudhary2/AI-Mock-Interview-Platform</a:t>
+              <a:t>DEPLOYMENT LINK:</a:t>
+            </a:r>
+            <a:br/>
+            <a:r>
+              <a:t>https://huggingface.co/spaces/tejashrichoudhary2/AI-Mock-Interview-Platform</a:t>
             </a:r>
           </a:p>
           <a:p>
             <a:pPr>
-              <a:defRPr sz="1300" b="1">
-                <a:solidFill>
-                  <a:srgbClr val="6366F1"/>
+              <a:defRPr sz="1100" b="1">
+                <a:solidFill>
+                  <a:srgbClr val="F8FAFC"/>
                 </a:solidFill>
                 <a:latin typeface="Arial"/>
               </a:defRPr>
             </a:pPr>
             <a:r>
-              <a:t>GITHUB REPOSITORY: https://github.com/tejashri-del098/AI-Mock-Interview-Platform</a:t>
-            </a:r>
-          </a:p>
-        </p:txBody>
-      </p:sp>
+              <a:t>GITHUB REPOSITORY:</a:t>
+            </a:r>
+            <a:br/>
+            <a:r>
+              <a:t>https://github.com/tejashri-del098/AI-Mock-Interview-Platform</a:t>
+            </a:r>
+          </a:p>
+        </p:txBody>
+      </p:sp>
+      <p:pic>
+        <p:nvPicPr>
+          <p:cNvPr id="6" name="Picture 5" descr="system_architecture_diagram.png"/>
+          <p:cNvPicPr>
+            <a:picLocks noChangeAspect="1"/>
+          </p:cNvPicPr>
+          <p:nvPr/>
+        </p:nvPicPr>
+        <p:blipFill>
+          <a:blip r:embed="rId2"/>
+          <a:stretch>
+            <a:fillRect/>
+          </a:stretch>
+        </p:blipFill>
+        <p:spPr>
+          <a:xfrm>
+            <a:off x="6309360" y="1645920"/>
+            <a:ext cx="5120640" cy="5120640"/>
+          </a:xfrm>
+          <a:prstGeom prst="rect">
+            <a:avLst/>
+          </a:prstGeom>
+        </p:spPr>
+      </p:pic>
     </p:spTree>
   </p:cSld>
   <p:clrMapOvr>

</xml_diff>

<commit_message>
docs: improve PowerPoint layout with tables, cards, and clickable hyperlinks
</commit_message>
<xml_diff>
--- a/assets/AI_Mock_Interview_Platform_Presentation.pptx
+++ b/assets/AI_Mock_Interview_Platform_Presentation.pptx
@@ -3108,7 +3108,7 @@
             <a:avLst/>
           </a:prstGeom>
           <a:solidFill>
-            <a:srgbClr val="0F172A"/>
+            <a:srgbClr val="0B0F19"/>
           </a:solidFill>
           <a:ln>
             <a:noFill/>
@@ -3138,82 +3138,14 @@
       </p:sp>
       <p:sp>
         <p:nvSpPr>
-          <p:cNvPr id="3" name="TextBox 2"/>
-          <p:cNvSpPr txBox="1"/>
+          <p:cNvPr id="3" name="Rectangle 2"/>
+          <p:cNvSpPr/>
           <p:nvPr/>
         </p:nvSpPr>
         <p:spPr>
           <a:xfrm>
-            <a:off x="914400" y="2011680"/>
-            <a:ext cx="10332720" cy="2743200"/>
-          </a:xfrm>
-          <a:prstGeom prst="rect">
-            <a:avLst/>
-          </a:prstGeom>
-          <a:noFill/>
-        </p:spPr>
-        <p:txBody>
-          <a:bodyPr wrap="square" lIns="0" tIns="0" rIns="0" bIns="0">
-            <a:spAutoFit/>
-          </a:bodyPr>
-          <a:lstStyle/>
-          <a:p>
-            <a:pPr>
-              <a:spcAft>
-                <a:spcPts val="800"/>
-              </a:spcAft>
-              <a:defRPr sz="1200" b="1">
-                <a:solidFill>
-                  <a:srgbClr val="2DD4BF"/>
-                </a:solidFill>
-                <a:latin typeface="Arial"/>
-              </a:defRPr>
-            </a:pPr>
-            <a:r>
-              <a:t>HACKATHON PRESENTATION</a:t>
-            </a:r>
-          </a:p>
-          <a:p>
-            <a:pPr>
-              <a:defRPr sz="4800" b="1">
-                <a:solidFill>
-                  <a:srgbClr val="F8FAFC"/>
-                </a:solidFill>
-                <a:latin typeface="Arial"/>
-              </a:defRPr>
-            </a:pPr>
-            <a:r>
-              <a:t>AI Mock Interview Platform</a:t>
-            </a:r>
-          </a:p>
-          <a:p>
-            <a:pPr>
-              <a:spcBef>
-                <a:spcPts val="3600"/>
-              </a:spcBef>
-              <a:defRPr sz="1800">
-                <a:solidFill>
-                  <a:srgbClr val="94A3B8"/>
-                </a:solidFill>
-                <a:latin typeface="Arial"/>
-              </a:defRPr>
-            </a:pPr>
-            <a:r>
-              <a:t>Personalized, Speech-Enabled technical recruiter simulation powered by local RAG</a:t>
-            </a:r>
-          </a:p>
-        </p:txBody>
-      </p:sp>
-      <p:sp>
-        <p:nvSpPr>
-          <p:cNvPr id="4" name="Rectangle 3"/>
-          <p:cNvSpPr/>
-          <p:nvPr/>
-        </p:nvSpPr>
-        <p:spPr>
-          <a:xfrm>
-            <a:off x="914400" y="3931920"/>
-            <a:ext cx="4114800" cy="54864"/>
+            <a:off x="731520" y="1645920"/>
+            <a:ext cx="73152" cy="2926080"/>
           </a:xfrm>
           <a:prstGeom prst="rect">
             <a:avLst/>
@@ -3247,6 +3179,109 @@
           </a:p>
         </p:txBody>
       </p:sp>
+      <p:sp>
+        <p:nvSpPr>
+          <p:cNvPr id="4" name="TextBox 3"/>
+          <p:cNvSpPr txBox="1"/>
+          <p:nvPr/>
+        </p:nvSpPr>
+        <p:spPr>
+          <a:xfrm>
+            <a:off x="1005840" y="1554480"/>
+            <a:ext cx="10058400" cy="3200400"/>
+          </a:xfrm>
+          <a:prstGeom prst="rect">
+            <a:avLst/>
+          </a:prstGeom>
+          <a:noFill/>
+        </p:spPr>
+        <p:txBody>
+          <a:bodyPr wrap="square" lIns="0" tIns="0" rIns="0" bIns="0">
+            <a:spAutoFit/>
+          </a:bodyPr>
+          <a:lstStyle/>
+          <a:p>
+            <a:pPr>
+              <a:defRPr sz="1200" b="1">
+                <a:solidFill>
+                  <a:srgbClr val="2DD4BF"/>
+                </a:solidFill>
+                <a:latin typeface="Arial"/>
+              </a:defRPr>
+            </a:pPr>
+            <a:r>
+              <a:t>AI TECHNICAL MOCK RECRUITER RECRUITING SUITE</a:t>
+            </a:r>
+          </a:p>
+          <a:p>
+            <a:pPr>
+              <a:spcBef>
+                <a:spcPts val="800"/>
+              </a:spcBef>
+              <a:defRPr sz="4600" b="1">
+                <a:solidFill>
+                  <a:srgbClr val="F8FAFC"/>
+                </a:solidFill>
+                <a:latin typeface="Arial"/>
+              </a:defRPr>
+            </a:pPr>
+            <a:r>
+              <a:t>AI Mock Interview Platform</a:t>
+            </a:r>
+          </a:p>
+          <a:p>
+            <a:pPr>
+              <a:spcBef>
+                <a:spcPts val="1200"/>
+              </a:spcBef>
+              <a:defRPr sz="1800">
+                <a:solidFill>
+                  <a:srgbClr val="94A3B8"/>
+                </a:solidFill>
+                <a:latin typeface="Arial"/>
+              </a:defRPr>
+            </a:pPr>
+            <a:r>
+              <a:t>A local RAG-powered, speech-enabled simulation platform for engineering candidates</a:t>
+            </a:r>
+          </a:p>
+          <a:p>
+            <a:pPr>
+              <a:spcBef>
+                <a:spcPts val="3600"/>
+              </a:spcBef>
+            </a:pPr>
+            <a:r>
+              <a:rPr sz="1500" b="1" u="sng">
+                <a:solidFill>
+                  <a:srgbClr val="2DD4BF"/>
+                </a:solidFill>
+                <a:latin typeface="Arial"/>
+                <a:hlinkClick r:id="rId2"/>
+              </a:rPr>
+              <a:t>🚀 Launch Live App on Hugging Face</a:t>
+            </a:r>
+            <a:r>
+              <a:rPr sz="1500">
+                <a:solidFill>
+                  <a:srgbClr val="94A3B8"/>
+                </a:solidFill>
+              </a:rPr>
+              <a:t>   |   </a:t>
+            </a:r>
+            <a:r>
+              <a:rPr sz="1500" b="1" u="sng">
+                <a:solidFill>
+                  <a:srgbClr val="6366F1"/>
+                </a:solidFill>
+                <a:latin typeface="Arial"/>
+                <a:hlinkClick r:id="rId3"/>
+              </a:rPr>
+              <a:t>💻 Access Source Code on GitHub</a:t>
+            </a:r>
+          </a:p>
+        </p:txBody>
+      </p:sp>
     </p:spTree>
   </p:cSld>
   <p:clrMapOvr>
@@ -3280,7 +3315,7 @@
             <a:avLst/>
           </a:prstGeom>
           <a:solidFill>
-            <a:srgbClr val="0F172A"/>
+            <a:srgbClr val="0B0F19"/>
           </a:solidFill>
           <a:ln>
             <a:noFill/>
@@ -3316,7 +3351,7 @@
         </p:nvSpPr>
         <p:spPr>
           <a:xfrm>
-            <a:off x="731520" y="457200"/>
+            <a:off x="731520" y="365760"/>
             <a:ext cx="10698480" cy="1097280"/>
           </a:xfrm>
           <a:prstGeom prst="rect">
@@ -3339,7 +3374,7 @@
               </a:defRPr>
             </a:pPr>
             <a:r>
-              <a:t>AI MOCK INTERVIEW PLATFORM</a:t>
+              <a:t>HACKATHON DELIVERABLE</a:t>
             </a:r>
           </a:p>
           <a:p>
@@ -3347,7 +3382,7 @@
               <a:spcBef>
                 <a:spcPts val="400"/>
               </a:spcBef>
-              <a:defRPr sz="2800" b="1">
+              <a:defRPr sz="2600" b="1">
                 <a:solidFill>
                   <a:srgbClr val="F8FAFC"/>
                 </a:solidFill>
@@ -3362,14 +3397,59 @@
       </p:sp>
       <p:sp>
         <p:nvSpPr>
-          <p:cNvPr id="4" name="TextBox 3"/>
-          <p:cNvSpPr txBox="1"/>
+          <p:cNvPr id="4" name="Rounded Rectangle 3"/>
+          <p:cNvSpPr/>
           <p:nvPr/>
         </p:nvSpPr>
         <p:spPr>
           <a:xfrm>
             <a:off x="731520" y="1645920"/>
             <a:ext cx="5120640" cy="4389120"/>
+          </a:xfrm>
+          <a:prstGeom prst="roundRect">
+            <a:avLst/>
+          </a:prstGeom>
+          <a:solidFill>
+            <a:srgbClr val="161C2D"/>
+          </a:solidFill>
+          <a:ln w="19050">
+            <a:solidFill>
+              <a:srgbClr val="EF4444"/>
+            </a:solidFill>
+          </a:ln>
+        </p:spPr>
+        <p:style>
+          <a:lnRef idx="1">
+            <a:schemeClr val="accent1"/>
+          </a:lnRef>
+          <a:fillRef idx="3">
+            <a:schemeClr val="accent1"/>
+          </a:fillRef>
+          <a:effectRef idx="2">
+            <a:schemeClr val="accent1"/>
+          </a:effectRef>
+          <a:fontRef idx="minor">
+            <a:schemeClr val="lt1"/>
+          </a:fontRef>
+        </p:style>
+        <p:txBody>
+          <a:bodyPr rtlCol="0" anchor="ctr"/>
+          <a:lstStyle/>
+          <a:p>
+            <a:pPr algn="ctr"/>
+          </a:p>
+        </p:txBody>
+      </p:sp>
+      <p:sp>
+        <p:nvSpPr>
+          <p:cNvPr id="5" name="TextBox 4"/>
+          <p:cNvSpPr txBox="1"/>
+          <p:nvPr/>
+        </p:nvSpPr>
+        <p:spPr>
+          <a:xfrm>
+            <a:off x="1005840" y="1828800"/>
+            <a:ext cx="4572000" cy="4023360"/>
           </a:xfrm>
           <a:prstGeom prst="rect">
             <a:avLst/>
@@ -3388,13 +3468,13 @@
               </a:spcAft>
               <a:defRPr sz="1600" b="1">
                 <a:solidFill>
-                  <a:srgbClr val="6366F1"/>
+                  <a:srgbClr val="EF4444"/>
                 </a:solidFill>
                 <a:latin typeface="Arial"/>
               </a:defRPr>
             </a:pPr>
             <a:r>
-              <a:t>THE PROBLEM</a:t>
+              <a:t>THE RECRUITING GAPS</a:t>
             </a:r>
           </a:p>
           <a:p>
@@ -3402,7 +3482,7 @@
               <a:spcAft>
                 <a:spcPts val="1000"/>
               </a:spcAft>
-              <a:defRPr sz="1400">
+              <a:defRPr sz="1300">
                 <a:solidFill>
                   <a:srgbClr val="94A3B8"/>
                 </a:solidFill>
@@ -3410,7 +3490,7 @@
               </a:defRPr>
             </a:pPr>
             <a:r>
-              <a:t>•  Static Questionnaires: Standard mock prep fails to align questions with candidate's actual projects and experience.</a:t>
+              <a:t>•  Static Standard Prep: Standard question pools fail to evaluate actual resume claims, engineering stacks, or candidates' projects.</a:t>
             </a:r>
           </a:p>
           <a:p>
@@ -3418,7 +3498,7 @@
               <a:spcAft>
                 <a:spcPts val="1000"/>
               </a:spcAft>
-              <a:defRPr sz="1400">
+              <a:defRPr sz="1300">
                 <a:solidFill>
                   <a:srgbClr val="94A3B8"/>
                 </a:solidFill>
@@ -3426,7 +3506,7 @@
               </a:defRPr>
             </a:pPr>
             <a:r>
-              <a:t>•  Unrealistic Preparation: Typing responses does not simulate the pacing and pressure of live, spoken recruiter screens.</a:t>
+              <a:t>•  No Conversational Pressure: Typing code or text responses lacks the behavioral friction of a live spoken interview panel.</a:t>
             </a:r>
           </a:p>
           <a:p>
@@ -3434,7 +3514,7 @@
               <a:spcAft>
                 <a:spcPts val="1000"/>
               </a:spcAft>
-              <a:defRPr sz="1400">
+              <a:defRPr sz="1300">
                 <a:solidFill>
                   <a:srgbClr val="94A3B8"/>
                 </a:solidFill>
@@ -3442,7 +3522,7 @@
               </a:defRPr>
             </a:pPr>
             <a:r>
-              <a:t>•  Generic Feedback: Candidates get vague guidance without ideal answers mapped directly to their performance gaps.</a:t>
+              <a:t>•  Lack of Detailed Feedback: Feedback is generic and doesn't map exact model responses to optimal answers or study guides.</a:t>
             </a:r>
           </a:p>
           <a:p>
@@ -3450,7 +3530,7 @@
               <a:spcAft>
                 <a:spcPts val="1000"/>
               </a:spcAft>
-              <a:defRPr sz="1400">
+              <a:defRPr sz="1300">
                 <a:solidFill>
                   <a:srgbClr val="94A3B8"/>
                 </a:solidFill>
@@ -3458,21 +3538,66 @@
               </a:defRPr>
             </a:pPr>
             <a:r>
-              <a:t>•  Privacy &amp; Cost: Uploading resumes to commercial clouds raises privacy concerns, and API fees accumulate quickly.</a:t>
-            </a:r>
-          </a:p>
-        </p:txBody>
-      </p:sp>
-      <p:sp>
-        <p:nvSpPr>
-          <p:cNvPr id="5" name="TextBox 4"/>
-          <p:cNvSpPr txBox="1"/>
+              <a:t>•  Data Privacy &amp; Costs: Uploading sensitive resumes to external API services poses corporate compliance risks and mounts monthly bills.</a:t>
+            </a:r>
+          </a:p>
+        </p:txBody>
+      </p:sp>
+      <p:sp>
+        <p:nvSpPr>
+          <p:cNvPr id="6" name="Rounded Rectangle 5"/>
+          <p:cNvSpPr/>
           <p:nvPr/>
         </p:nvSpPr>
         <p:spPr>
           <a:xfrm>
             <a:off x="6309360" y="1645920"/>
             <a:ext cx="5120640" cy="4389120"/>
+          </a:xfrm>
+          <a:prstGeom prst="roundRect">
+            <a:avLst/>
+          </a:prstGeom>
+          <a:solidFill>
+            <a:srgbClr val="161C2D"/>
+          </a:solidFill>
+          <a:ln w="19050">
+            <a:solidFill>
+              <a:srgbClr val="2DD4BF"/>
+            </a:solidFill>
+          </a:ln>
+        </p:spPr>
+        <p:style>
+          <a:lnRef idx="1">
+            <a:schemeClr val="accent1"/>
+          </a:lnRef>
+          <a:fillRef idx="3">
+            <a:schemeClr val="accent1"/>
+          </a:fillRef>
+          <a:effectRef idx="2">
+            <a:schemeClr val="accent1"/>
+          </a:effectRef>
+          <a:fontRef idx="minor">
+            <a:schemeClr val="lt1"/>
+          </a:fontRef>
+        </p:style>
+        <p:txBody>
+          <a:bodyPr rtlCol="0" anchor="ctr"/>
+          <a:lstStyle/>
+          <a:p>
+            <a:pPr algn="ctr"/>
+          </a:p>
+        </p:txBody>
+      </p:sp>
+      <p:sp>
+        <p:nvSpPr>
+          <p:cNvPr id="7" name="TextBox 6"/>
+          <p:cNvSpPr txBox="1"/>
+          <p:nvPr/>
+        </p:nvSpPr>
+        <p:spPr>
+          <a:xfrm>
+            <a:off x="6583680" y="1828800"/>
+            <a:ext cx="4572000" cy="4023360"/>
           </a:xfrm>
           <a:prstGeom prst="rect">
             <a:avLst/>
@@ -3497,7 +3622,7 @@
               </a:defRPr>
             </a:pPr>
             <a:r>
-              <a:t>THE SOLUTION</a:t>
+              <a:t>THE RAG RECRUITER SOLUTION</a:t>
             </a:r>
           </a:p>
           <a:p>
@@ -3505,7 +3630,7 @@
               <a:spcAft>
                 <a:spcPts val="1000"/>
               </a:spcAft>
-              <a:defRPr sz="1400">
+              <a:defRPr sz="1300">
                 <a:solidFill>
                   <a:srgbClr val="F8FAFC"/>
                 </a:solidFill>
@@ -3513,7 +3638,7 @@
               </a:defRPr>
             </a:pPr>
             <a:r>
-              <a:t>•  Local RAG Core: Ingests resumes (PDF/Word/Text) and stores embeddings in ChromaDB to ask hyper-personalized, custom questions.</a:t>
+              <a:t>•  Contextual RAG Core: Ingests PDF/DOCX resumes, creating local ChromaDB vectors to prompt context-specific recruiting questions.</a:t>
             </a:r>
           </a:p>
           <a:p>
@@ -3521,7 +3646,7 @@
               <a:spcAft>
                 <a:spcPts val="1000"/>
               </a:spcAft>
-              <a:defRPr sz="1400">
+              <a:defRPr sz="1300">
                 <a:solidFill>
                   <a:srgbClr val="F8FAFC"/>
                 </a:solidFill>
@@ -3529,7 +3654,7 @@
               </a:defRPr>
             </a:pPr>
             <a:r>
-              <a:t>•  Speech Recruiter Loop: Audio questions (Edge TTS) and local microphone recorder (Whisper STT) recreate live pacing.</a:t>
+              <a:t>•  Speech rec/generation loop: Custom micro-audio canvas record module (Whisper STT) and Edge TTS voice output mimic live pacing.</a:t>
             </a:r>
           </a:p>
           <a:p>
@@ -3537,7 +3662,7 @@
               <a:spcAft>
                 <a:spcPts val="1000"/>
               </a:spcAft>
-              <a:defRPr sz="1400">
+              <a:defRPr sz="1300">
                 <a:solidFill>
                   <a:srgbClr val="F8FAFC"/>
                 </a:solidFill>
@@ -3545,7 +3670,7 @@
               </a:defRPr>
             </a:pPr>
             <a:r>
-              <a:t>•  Actionable Assessment: Generates structured technical, communication, and relevance scoring dashboards.</a:t>
+              <a:t>•  Actionable Assessment: Renders interactive charts showing candidate score breakdowns in technical accuracy, style, and relevance.</a:t>
             </a:r>
           </a:p>
           <a:p>
@@ -3553,7 +3678,7 @@
               <a:spcAft>
                 <a:spcPts val="1000"/>
               </a:spcAft>
-              <a:defRPr sz="1400">
+              <a:defRPr sz="1300">
                 <a:solidFill>
                   <a:srgbClr val="F8FAFC"/>
                 </a:solidFill>
@@ -3561,7 +3686,7 @@
               </a:defRPr>
             </a:pPr>
             <a:r>
-              <a:t>•  Headless PDF Generation: Exports a diagnostic scorecard, ideal responses, and study syllabus instantly.</a:t>
+              <a:t>•  Headless PDF Report: Compiles feedback summaries, strengths, weaknesses, and study syllabus into a printable PDF.</a:t>
             </a:r>
           </a:p>
         </p:txBody>
@@ -3599,7 +3724,7 @@
             <a:avLst/>
           </a:prstGeom>
           <a:solidFill>
-            <a:srgbClr val="0F172A"/>
+            <a:srgbClr val="0B0F19"/>
           </a:solidFill>
           <a:ln>
             <a:noFill/>
@@ -3635,7 +3760,7 @@
         </p:nvSpPr>
         <p:spPr>
           <a:xfrm>
-            <a:off x="731520" y="457200"/>
+            <a:off x="731520" y="365760"/>
             <a:ext cx="10698480" cy="1097280"/>
           </a:xfrm>
           <a:prstGeom prst="rect">
@@ -3658,7 +3783,7 @@
               </a:defRPr>
             </a:pPr>
             <a:r>
-              <a:t>AI MOCK INTERVIEW PLATFORM</a:t>
+              <a:t>HACKATHON DELIVERABLE</a:t>
             </a:r>
           </a:p>
           <a:p>
@@ -3666,7 +3791,7 @@
               <a:spcBef>
                 <a:spcPts val="400"/>
               </a:spcBef>
-              <a:defRPr sz="2800" b="1">
+              <a:defRPr sz="2600" b="1">
                 <a:solidFill>
                   <a:srgbClr val="F8FAFC"/>
                 </a:solidFill>
@@ -3681,14 +3806,59 @@
       </p:sp>
       <p:sp>
         <p:nvSpPr>
-          <p:cNvPr id="4" name="TextBox 3"/>
-          <p:cNvSpPr txBox="1"/>
+          <p:cNvPr id="4" name="Rounded Rectangle 3"/>
+          <p:cNvSpPr/>
           <p:nvPr/>
         </p:nvSpPr>
         <p:spPr>
           <a:xfrm>
             <a:off x="731520" y="1645920"/>
-            <a:ext cx="5303520" cy="4206240"/>
+            <a:ext cx="5303520" cy="4572000"/>
+          </a:xfrm>
+          <a:prstGeom prst="roundRect">
+            <a:avLst/>
+          </a:prstGeom>
+          <a:solidFill>
+            <a:srgbClr val="161C2D"/>
+          </a:solidFill>
+          <a:ln w="19050">
+            <a:solidFill>
+              <a:srgbClr val="6366F1"/>
+            </a:solidFill>
+          </a:ln>
+        </p:spPr>
+        <p:style>
+          <a:lnRef idx="1">
+            <a:schemeClr val="accent1"/>
+          </a:lnRef>
+          <a:fillRef idx="3">
+            <a:schemeClr val="accent1"/>
+          </a:fillRef>
+          <a:effectRef idx="2">
+            <a:schemeClr val="accent1"/>
+          </a:effectRef>
+          <a:fontRef idx="minor">
+            <a:schemeClr val="lt1"/>
+          </a:fontRef>
+        </p:style>
+        <p:txBody>
+          <a:bodyPr rtlCol="0" anchor="ctr"/>
+          <a:lstStyle/>
+          <a:p>
+            <a:pPr algn="ctr"/>
+          </a:p>
+        </p:txBody>
+      </p:sp>
+      <p:sp>
+        <p:nvSpPr>
+          <p:cNvPr id="5" name="TextBox 4"/>
+          <p:cNvSpPr txBox="1"/>
+          <p:nvPr/>
+        </p:nvSpPr>
+        <p:spPr>
+          <a:xfrm>
+            <a:off x="1005840" y="1828800"/>
+            <a:ext cx="4754880" cy="4206240"/>
           </a:xfrm>
           <a:prstGeom prst="rect">
             <a:avLst/>
@@ -3703,7 +3873,7 @@
           <a:p>
             <a:pPr>
               <a:spcAft>
-                <a:spcPts val="1200"/>
+                <a:spcPts val="1400"/>
               </a:spcAft>
               <a:defRPr sz="1600" b="1">
                 <a:solidFill>
@@ -3713,7 +3883,7 @@
               </a:defRPr>
             </a:pPr>
             <a:r>
-              <a:t>Architecture &amp; Data Pipeline Flow:</a:t>
+              <a:t>DATA PIPELINE FLOW</a:t>
             </a:r>
           </a:p>
           <a:p>
@@ -3729,7 +3899,7 @@
               </a:defRPr>
             </a:pPr>
             <a:r>
-              <a:t>•  1. Ingestion: PDF/DOCX resumes are parsed, split, embedded, and cached in local ChromaDB.</a:t>
+              <a:t>•  Resume Parsing: Text chunks are extracted from PDF/DOCX/TXT files, embedded (all-MiniLM-L6-v2), and stored locally in ChromaDB.</a:t>
             </a:r>
           </a:p>
           <a:p>
@@ -3745,7 +3915,7 @@
               </a:defRPr>
             </a:pPr>
             <a:r>
-              <a:t>•  2. Recruiter Persona: FastAPI manages context, fetches semantic blocks, and calls LLM recruiter logic.</a:t>
+              <a:t>•  FastAPI State Gateway: Manages session variables, retrieves resume profiles, runs evaluations, and mounts static paths.</a:t>
             </a:r>
           </a:p>
           <a:p>
@@ -3761,7 +3931,7 @@
               </a:defRPr>
             </a:pPr>
             <a:r>
-              <a:t>•  3. Speech Loop: Converts questions to audio (Edge TTS); candidate speaks and Whisper STT transcribes it locally.</a:t>
+              <a:t>•  Microphone STT: Custom browser microphone recorder sends chunks to local Whisper Tiny model for latency-free offline transcripts.</a:t>
             </a:r>
           </a:p>
           <a:p>
@@ -3777,89 +3947,109 @@
               </a:defRPr>
             </a:pPr>
             <a:r>
-              <a:t>•  4. Proxy Integration: Single entrypoint (Nginx) routes Streamlit websockets &amp; FastAPI endpoints securely.</a:t>
-            </a:r>
-          </a:p>
-        </p:txBody>
-      </p:sp>
-      <p:sp>
-        <p:nvSpPr>
-          <p:cNvPr id="5" name="TextBox 4"/>
-          <p:cNvSpPr txBox="1"/>
+              <a:t>•  Nginx Proxy routing: Port 7860 handles HTTP requests (/api), streams audio (/static/audio), and opens Streamlit WebSockets.</a:t>
+            </a:r>
+          </a:p>
+          <a:p>
+            <a:pPr>
+              <a:spcBef>
+                <a:spcPts val="1400"/>
+              </a:spcBef>
+            </a:pPr>
+            <a:r>
+              <a:rPr sz="1200" b="1" u="sng">
+                <a:solidFill>
+                  <a:srgbClr val="2DD4BF"/>
+                </a:solidFill>
+                <a:latin typeface="Arial"/>
+                <a:hlinkClick r:id="rId2"/>
+              </a:rPr>
+              <a:t>🔗 Click Here to Launch HF Space</a:t>
+            </a:r>
+            <a:r>
+              <a:rPr>
+                <a:solidFill>
+                  <a:srgbClr val="94A3B8"/>
+                </a:solidFill>
+              </a:rPr>
+              <a:t>  |  </a:t>
+            </a:r>
+            <a:r>
+              <a:rPr sz="1200" b="1" u="sng">
+                <a:solidFill>
+                  <a:srgbClr val="6366F1"/>
+                </a:solidFill>
+                <a:latin typeface="Arial"/>
+                <a:hlinkClick r:id="rId3"/>
+              </a:rPr>
+              <a:t>🔗 View GitHub</a:t>
+            </a:r>
+          </a:p>
+        </p:txBody>
+      </p:sp>
+      <p:sp>
+        <p:nvSpPr>
+          <p:cNvPr id="6" name="Rounded Rectangle 5"/>
+          <p:cNvSpPr/>
           <p:nvPr/>
         </p:nvSpPr>
         <p:spPr>
           <a:xfrm>
-            <a:off x="731520" y="4937760"/>
-            <a:ext cx="5303520" cy="1463040"/>
+            <a:off x="6217920" y="1645920"/>
+            <a:ext cx="5212080" cy="4572000"/>
           </a:xfrm>
-          <a:prstGeom prst="rect">
+          <a:prstGeom prst="roundRect">
             <a:avLst/>
           </a:prstGeom>
-          <a:noFill/>
+          <a:solidFill>
+            <a:srgbClr val="161C2D"/>
+          </a:solidFill>
+          <a:ln w="19050">
+            <a:solidFill>
+              <a:srgbClr val="2DD4BF"/>
+            </a:solidFill>
+          </a:ln>
         </p:spPr>
-        <p:txBody>
-          <a:bodyPr wrap="square" lIns="0" tIns="0" rIns="0" bIns="0">
-            <a:spAutoFit/>
-          </a:bodyPr>
-          <a:lstStyle/>
-          <a:p>
-            <a:pPr>
-              <a:spcAft>
-                <a:spcPts val="800"/>
-              </a:spcAft>
-              <a:defRPr sz="1100" b="1">
-                <a:solidFill>
-                  <a:srgbClr val="2DD4BF"/>
-                </a:solidFill>
-                <a:latin typeface="Arial"/>
-              </a:defRPr>
-            </a:pPr>
-            <a:r>
-              <a:t>DEPLOYMENT LINK:</a:t>
-            </a:r>
-            <a:br/>
-            <a:r>
-              <a:t>https://huggingface.co/spaces/tejashrichoudhary2/AI-Mock-Interview-Platform</a:t>
-            </a:r>
-          </a:p>
-          <a:p>
-            <a:pPr>
-              <a:defRPr sz="1100" b="1">
-                <a:solidFill>
-                  <a:srgbClr val="F8FAFC"/>
-                </a:solidFill>
-                <a:latin typeface="Arial"/>
-              </a:defRPr>
-            </a:pPr>
-            <a:r>
-              <a:t>GITHUB REPOSITORY:</a:t>
-            </a:r>
-            <a:br/>
-            <a:r>
-              <a:t>https://github.com/tejashri-del098/AI-Mock-Interview-Platform</a:t>
-            </a:r>
+        <p:style>
+          <a:lnRef idx="1">
+            <a:schemeClr val="accent1"/>
+          </a:lnRef>
+          <a:fillRef idx="3">
+            <a:schemeClr val="accent1"/>
+          </a:fillRef>
+          <a:effectRef idx="2">
+            <a:schemeClr val="accent1"/>
+          </a:effectRef>
+          <a:fontRef idx="minor">
+            <a:schemeClr val="lt1"/>
+          </a:fontRef>
+        </p:style>
+        <p:txBody>
+          <a:bodyPr rtlCol="0" anchor="ctr"/>
+          <a:lstStyle/>
+          <a:p>
+            <a:pPr algn="ctr"/>
           </a:p>
         </p:txBody>
       </p:sp>
       <p:pic>
         <p:nvPicPr>
-          <p:cNvPr id="6" name="Picture 5" descr="system_architecture_diagram.png"/>
+          <p:cNvPr id="7" name="Picture 6" descr="system_architecture_diagram.png"/>
           <p:cNvPicPr>
             <a:picLocks noChangeAspect="1"/>
           </p:cNvPicPr>
           <p:nvPr/>
         </p:nvPicPr>
         <p:blipFill>
-          <a:blip r:embed="rId2"/>
+          <a:blip r:embed="rId4"/>
           <a:stretch>
             <a:fillRect/>
           </a:stretch>
         </p:blipFill>
         <p:spPr>
           <a:xfrm>
-            <a:off x="6309360" y="1645920"/>
-            <a:ext cx="5120640" cy="5120640"/>
+            <a:off x="6400800" y="2103120"/>
+            <a:ext cx="4846320" cy="4846320"/>
           </a:xfrm>
           <a:prstGeom prst="rect">
             <a:avLst/>
@@ -3899,7 +4089,7 @@
             <a:avLst/>
           </a:prstGeom>
           <a:solidFill>
-            <a:srgbClr val="0F172A"/>
+            <a:srgbClr val="0B0F19"/>
           </a:solidFill>
           <a:ln>
             <a:noFill/>
@@ -3935,7 +4125,7 @@
         </p:nvSpPr>
         <p:spPr>
           <a:xfrm>
-            <a:off x="731520" y="457200"/>
+            <a:off x="731520" y="365760"/>
             <a:ext cx="10698480" cy="1097280"/>
           </a:xfrm>
           <a:prstGeom prst="rect">
@@ -3958,7 +4148,7 @@
               </a:defRPr>
             </a:pPr>
             <a:r>
-              <a:t>AI MOCK INTERVIEW PLATFORM</a:t>
+              <a:t>HACKATHON DELIVERABLE</a:t>
             </a:r>
           </a:p>
           <a:p>
@@ -3966,7 +4156,7 @@
               <a:spcBef>
                 <a:spcPts val="400"/>
               </a:spcBef>
-              <a:defRPr sz="2800" b="1">
+              <a:defRPr sz="2600" b="1">
                 <a:solidFill>
                   <a:srgbClr val="F8FAFC"/>
                 </a:solidFill>
@@ -3974,179 +4164,393 @@
               </a:defRPr>
             </a:pPr>
             <a:r>
-              <a:t>Tech Stack &amp; Rationale</a:t>
-            </a:r>
-          </a:p>
-        </p:txBody>
-      </p:sp>
-      <p:sp>
-        <p:nvSpPr>
-          <p:cNvPr id="4" name="TextBox 3"/>
-          <p:cNvSpPr txBox="1"/>
+              <a:t>Tech Stack &amp; Rationale Comparison</a:t>
+            </a:r>
+          </a:p>
+        </p:txBody>
+      </p:sp>
+      <p:graphicFrame>
+        <p:nvGraphicFramePr>
+          <p:cNvPr id="4" name="Table 3"/>
+          <p:cNvGraphicFramePr>
+            <a:graphicFrameLocks noGrp="1"/>
+          </p:cNvGraphicFramePr>
           <p:nvPr/>
-        </p:nvSpPr>
-        <p:spPr>
-          <a:xfrm>
-            <a:off x="731520" y="1645920"/>
-            <a:ext cx="5120640" cy="4389120"/>
-          </a:xfrm>
-          <a:prstGeom prst="rect">
-            <a:avLst/>
-          </a:prstGeom>
-          <a:noFill/>
-        </p:spPr>
-        <p:txBody>
-          <a:bodyPr wrap="square" lIns="0" tIns="0" rIns="0" bIns="0">
-            <a:spAutoFit/>
-          </a:bodyPr>
-          <a:lstStyle/>
-          <a:p>
-            <a:pPr>
-              <a:defRPr sz="1500" b="1">
-                <a:solidFill>
-                  <a:srgbClr val="2DD4BF"/>
-                </a:solidFill>
-                <a:latin typeface="Arial"/>
-              </a:defRPr>
-            </a:pPr>
-            <a:r>
-              <a:t>Streamlit vs React/HTML</a:t>
-            </a:r>
-          </a:p>
-          <a:p>
-            <a:pPr>
-              <a:spcBef>
-                <a:spcPts val="400"/>
-              </a:spcBef>
-              <a:defRPr sz="1300">
-                <a:solidFill>
-                  <a:srgbClr val="94A3B8"/>
-                </a:solidFill>
-                <a:latin typeface="Arial"/>
-              </a:defRPr>
-            </a:pPr>
-            <a:r>
-              <a:t>Allows constructing data-intensive dashboards in 100% Python with native state management. We embedded bi-directional HTML5 modules to capture micro-audio inputs without adding web server bloat.</a:t>
-            </a:r>
-          </a:p>
-          <a:p>
-            <a:pPr>
-              <a:spcBef>
-                <a:spcPts val="1600"/>
-              </a:spcBef>
-              <a:defRPr sz="1500" b="1">
-                <a:solidFill>
-                  <a:srgbClr val="2DD4BF"/>
-                </a:solidFill>
-                <a:latin typeface="Arial"/>
-              </a:defRPr>
-            </a:pPr>
-            <a:r>
-              <a:t>FastAPI vs Flask/Django</a:t>
-            </a:r>
-          </a:p>
-          <a:p>
-            <a:pPr>
-              <a:spcBef>
-                <a:spcPts val="400"/>
-              </a:spcBef>
-              <a:defRPr sz="1300">
-                <a:solidFill>
-                  <a:srgbClr val="94A3B8"/>
-                </a:solidFill>
-                <a:latin typeface="Arial"/>
-              </a:defRPr>
-            </a:pPr>
-            <a:r>
-              <a:t>Provides native async/await capabilities, which is crucial for handling concurrently streaming Edge TTS voice generation, local Whisper transcripts, and multi-part file uploads.</a:t>
-            </a:r>
-          </a:p>
-        </p:txBody>
-      </p:sp>
-      <p:sp>
-        <p:nvSpPr>
-          <p:cNvPr id="5" name="TextBox 4"/>
-          <p:cNvSpPr txBox="1"/>
-          <p:nvPr/>
-        </p:nvSpPr>
-        <p:spPr>
-          <a:xfrm>
-            <a:off x="6309360" y="1645920"/>
-            <a:ext cx="5120640" cy="4389120"/>
-          </a:xfrm>
-          <a:prstGeom prst="rect">
-            <a:avLst/>
-          </a:prstGeom>
-          <a:noFill/>
-        </p:spPr>
-        <p:txBody>
-          <a:bodyPr wrap="square" lIns="0" tIns="0" rIns="0" bIns="0">
-            <a:spAutoFit/>
-          </a:bodyPr>
-          <a:lstStyle/>
-          <a:p>
-            <a:pPr>
-              <a:defRPr sz="1500" b="1">
-                <a:solidFill>
-                  <a:srgbClr val="6366F1"/>
-                </a:solidFill>
-                <a:latin typeface="Arial"/>
-              </a:defRPr>
-            </a:pPr>
-            <a:r>
-              <a:t>ChromaDB &amp; HF Embeddings vs Pinecone</a:t>
-            </a:r>
-          </a:p>
-          <a:p>
-            <a:pPr>
-              <a:spcBef>
-                <a:spcPts val="400"/>
-              </a:spcBef>
-              <a:defRPr sz="1300">
-                <a:solidFill>
-                  <a:srgbClr val="F8FAFC"/>
-                </a:solidFill>
-                <a:latin typeface="Arial"/>
-              </a:defRPr>
-            </a:pPr>
-            <a:r>
-              <a:t>Operates entirely offline/locally without managing cloud API credentials. sentence-transformers yields robust, compact 384-dimensional semantic arrays at zero host costs.</a:t>
-            </a:r>
-          </a:p>
-          <a:p>
-            <a:pPr>
-              <a:spcBef>
-                <a:spcPts val="1600"/>
-              </a:spcBef>
-              <a:defRPr sz="1500" b="1">
-                <a:solidFill>
-                  <a:srgbClr val="6366F1"/>
-                </a:solidFill>
-                <a:latin typeface="Arial"/>
-              </a:defRPr>
-            </a:pPr>
-            <a:r>
-              <a:t>Edge TTS &amp; Whisper vs ElevenLabs/Google STT</a:t>
-            </a:r>
-          </a:p>
-          <a:p>
-            <a:pPr>
-              <a:spcBef>
-                <a:spcPts val="400"/>
-              </a:spcBef>
-              <a:defRPr sz="1300">
-                <a:solidFill>
-                  <a:srgbClr val="F8FAFC"/>
-                </a:solidFill>
-                <a:latin typeface="Arial"/>
-              </a:defRPr>
-            </a:pPr>
-            <a:r>
-              <a:t>Edge TTS renders organic-sounding neural voices asynchronously for free, while local cached Whisper weights perform containerized Speech-to-Text with unlimited quotas.</a:t>
-            </a:r>
-          </a:p>
-        </p:txBody>
-      </p:sp>
+        </p:nvGraphicFramePr>
+        <p:xfrm>
+          <a:off x="731520" y="1645920"/>
+          <a:ext cx="10698480" cy="4572000"/>
+        </p:xfrm>
+        <a:graphic>
+          <a:graphicData uri="http://schemas.openxmlformats.org/drawingml/2006/table">
+            <a:tbl>
+              <a:tblPr firstRow="1" bandRow="1">
+                <a:tableStyleId>{5C22544A-7EE6-4342-B048-85BDC9FD1C3A}</a:tableStyleId>
+              </a:tblPr>
+              <a:tblGrid>
+                <a:gridCol w="2286000"/>
+                <a:gridCol w="2743200"/>
+                <a:gridCol w="5669280"/>
+              </a:tblGrid>
+              <a:tr h="914400">
+                <a:tc>
+                  <a:txBody>
+                    <a:bodyPr/>
+                    <a:lstStyle/>
+                    <a:p>
+                      <a:pPr algn="l"/>
+                      <a:r>
+                        <a:rPr sz="1300" b="1">
+                          <a:solidFill>
+                            <a:srgbClr val="2DD4BF"/>
+                          </a:solidFill>
+                          <a:latin typeface="Arial"/>
+                        </a:rPr>
+                        <a:t>COMPONENT LAYER</a:t>
+                      </a:r>
+                    </a:p>
+                  </a:txBody>
+                  <a:tcPr>
+                    <a:solidFill>
+                      <a:srgbClr val="161C2D"/>
+                    </a:solidFill>
+                  </a:tcPr>
+                </a:tc>
+                <a:tc>
+                  <a:txBody>
+                    <a:bodyPr/>
+                    <a:lstStyle/>
+                    <a:p>
+                      <a:pPr algn="l"/>
+                      <a:r>
+                        <a:rPr sz="1300" b="1">
+                          <a:solidFill>
+                            <a:srgbClr val="2DD4BF"/>
+                          </a:solidFill>
+                          <a:latin typeface="Arial"/>
+                        </a:rPr>
+                        <a:t>CHOSEN TECHNOLOGY</a:t>
+                      </a:r>
+                    </a:p>
+                  </a:txBody>
+                  <a:tcPr>
+                    <a:solidFill>
+                      <a:srgbClr val="161C2D"/>
+                    </a:solidFill>
+                  </a:tcPr>
+                </a:tc>
+                <a:tc>
+                  <a:txBody>
+                    <a:bodyPr/>
+                    <a:lstStyle/>
+                    <a:p>
+                      <a:pPr algn="l"/>
+                      <a:r>
+                        <a:rPr sz="1300" b="1">
+                          <a:solidFill>
+                            <a:srgbClr val="2DD4BF"/>
+                          </a:solidFill>
+                          <a:latin typeface="Arial"/>
+                        </a:rPr>
+                        <a:t>RATIONALE vs ALTERNATIVES</a:t>
+                      </a:r>
+                    </a:p>
+                  </a:txBody>
+                  <a:tcPr>
+                    <a:solidFill>
+                      <a:srgbClr val="161C2D"/>
+                    </a:solidFill>
+                  </a:tcPr>
+                </a:tc>
+              </a:tr>
+              <a:tr h="914400">
+                <a:tc>
+                  <a:txBody>
+                    <a:bodyPr/>
+                    <a:lstStyle/>
+                    <a:p>
+                      <a:pPr algn="l"/>
+                      <a:r>
+                        <a:rPr sz="1200" b="1">
+                          <a:solidFill>
+                            <a:srgbClr val="F8FAFC"/>
+                          </a:solidFill>
+                          <a:latin typeface="Arial"/>
+                        </a:rPr>
+                        <a:t>Frontend Interface</a:t>
+                      </a:r>
+                    </a:p>
+                  </a:txBody>
+                  <a:tcPr>
+                    <a:solidFill>
+                      <a:srgbClr val="0B0F19"/>
+                    </a:solidFill>
+                  </a:tcPr>
+                </a:tc>
+                <a:tc>
+                  <a:txBody>
+                    <a:bodyPr/>
+                    <a:lstStyle/>
+                    <a:p>
+                      <a:pPr algn="l"/>
+                      <a:r>
+                        <a:rPr sz="1200" b="1">
+                          <a:solidFill>
+                            <a:srgbClr val="6366F1"/>
+                          </a:solidFill>
+                          <a:latin typeface="Arial"/>
+                        </a:rPr>
+                        <a:t>Streamlit (Slate Dark Theme)</a:t>
+                      </a:r>
+                    </a:p>
+                  </a:txBody>
+                  <a:tcPr>
+                    <a:solidFill>
+                      <a:srgbClr val="0B0F19"/>
+                    </a:solidFill>
+                  </a:tcPr>
+                </a:tc>
+                <a:tc>
+                  <a:txBody>
+                    <a:bodyPr/>
+                    <a:lstStyle/>
+                    <a:p>
+                      <a:pPr algn="l"/>
+                      <a:r>
+                        <a:rPr sz="1200">
+                          <a:solidFill>
+                            <a:srgbClr val="94A3B8"/>
+                          </a:solidFill>
+                          <a:latin typeface="Arial"/>
+                        </a:rPr>
+                        <a:t>Fast UI building in pure Python. Houses bi-directional custom components for audio recordings and web analytics; beats React development overhead for mockups.</a:t>
+                      </a:r>
+                    </a:p>
+                  </a:txBody>
+                  <a:tcPr>
+                    <a:solidFill>
+                      <a:srgbClr val="0B0F19"/>
+                    </a:solidFill>
+                  </a:tcPr>
+                </a:tc>
+              </a:tr>
+              <a:tr h="914400">
+                <a:tc>
+                  <a:txBody>
+                    <a:bodyPr/>
+                    <a:lstStyle/>
+                    <a:p>
+                      <a:pPr algn="l"/>
+                      <a:r>
+                        <a:rPr sz="1200" b="1">
+                          <a:solidFill>
+                            <a:srgbClr val="F8FAFC"/>
+                          </a:solidFill>
+                          <a:latin typeface="Arial"/>
+                        </a:rPr>
+                        <a:t>Backend API Gateway</a:t>
+                      </a:r>
+                    </a:p>
+                  </a:txBody>
+                  <a:tcPr>
+                    <a:solidFill>
+                      <a:srgbClr val="161C2D"/>
+                    </a:solidFill>
+                  </a:tcPr>
+                </a:tc>
+                <a:tc>
+                  <a:txBody>
+                    <a:bodyPr/>
+                    <a:lstStyle/>
+                    <a:p>
+                      <a:pPr algn="l"/>
+                      <a:r>
+                        <a:rPr sz="1200" b="1">
+                          <a:solidFill>
+                            <a:srgbClr val="6366F1"/>
+                          </a:solidFill>
+                          <a:latin typeface="Arial"/>
+                        </a:rPr>
+                        <a:t>FastAPI (Uvicorn)</a:t>
+                      </a:r>
+                    </a:p>
+                  </a:txBody>
+                  <a:tcPr>
+                    <a:solidFill>
+                      <a:srgbClr val="161C2D"/>
+                    </a:solidFill>
+                  </a:tcPr>
+                </a:tc>
+                <a:tc>
+                  <a:txBody>
+                    <a:bodyPr/>
+                    <a:lstStyle/>
+                    <a:p>
+                      <a:pPr algn="l"/>
+                      <a:r>
+                        <a:rPr sz="1200">
+                          <a:solidFill>
+                            <a:srgbClr val="94A3B8"/>
+                          </a:solidFill>
+                          <a:latin typeface="Arial"/>
+                        </a:rPr>
+                        <a:t>Full async/await integration handles multiple parallel text-to-speech requests and Whisper audio uploads seamlessly; out-performs synchronous Flask.</a:t>
+                      </a:r>
+                    </a:p>
+                  </a:txBody>
+                  <a:tcPr>
+                    <a:solidFill>
+                      <a:srgbClr val="161C2D"/>
+                    </a:solidFill>
+                  </a:tcPr>
+                </a:tc>
+              </a:tr>
+              <a:tr h="914400">
+                <a:tc>
+                  <a:txBody>
+                    <a:bodyPr/>
+                    <a:lstStyle/>
+                    <a:p>
+                      <a:pPr algn="l"/>
+                      <a:r>
+                        <a:rPr sz="1200" b="1">
+                          <a:solidFill>
+                            <a:srgbClr val="F8FAFC"/>
+                          </a:solidFill>
+                          <a:latin typeface="Arial"/>
+                        </a:rPr>
+                        <a:t>RAG Vector Database</a:t>
+                      </a:r>
+                    </a:p>
+                  </a:txBody>
+                  <a:tcPr>
+                    <a:solidFill>
+                      <a:srgbClr val="0B0F19"/>
+                    </a:solidFill>
+                  </a:tcPr>
+                </a:tc>
+                <a:tc>
+                  <a:txBody>
+                    <a:bodyPr/>
+                    <a:lstStyle/>
+                    <a:p>
+                      <a:pPr algn="l"/>
+                      <a:r>
+                        <a:rPr sz="1200" b="1">
+                          <a:solidFill>
+                            <a:srgbClr val="6366F1"/>
+                          </a:solidFill>
+                          <a:latin typeface="Arial"/>
+                        </a:rPr>
+                        <a:t>ChromaDB (Local Persistent)</a:t>
+                      </a:r>
+                    </a:p>
+                  </a:txBody>
+                  <a:tcPr>
+                    <a:solidFill>
+                      <a:srgbClr val="0B0F19"/>
+                    </a:solidFill>
+                  </a:tcPr>
+                </a:tc>
+                <a:tc>
+                  <a:txBody>
+                    <a:bodyPr/>
+                    <a:lstStyle/>
+                    <a:p>
+                      <a:pPr algn="l"/>
+                      <a:r>
+                        <a:rPr sz="1200">
+                          <a:solidFill>
+                            <a:srgbClr val="94A3B8"/>
+                          </a:solidFill>
+                          <a:latin typeface="Arial"/>
+                        </a:rPr>
+                        <a:t>100% serverless and offline. Avoids network latency, paid Pinecone storage costs, and keeps resume embeddings completely private.</a:t>
+                      </a:r>
+                    </a:p>
+                  </a:txBody>
+                  <a:tcPr>
+                    <a:solidFill>
+                      <a:srgbClr val="0B0F19"/>
+                    </a:solidFill>
+                  </a:tcPr>
+                </a:tc>
+              </a:tr>
+              <a:tr h="914400">
+                <a:tc>
+                  <a:txBody>
+                    <a:bodyPr/>
+                    <a:lstStyle/>
+                    <a:p>
+                      <a:pPr algn="l"/>
+                      <a:r>
+                        <a:rPr sz="1200" b="1">
+                          <a:solidFill>
+                            <a:srgbClr val="F8FAFC"/>
+                          </a:solidFill>
+                          <a:latin typeface="Arial"/>
+                        </a:rPr>
+                        <a:t>Recruiting Audio Pipeline</a:t>
+                      </a:r>
+                    </a:p>
+                  </a:txBody>
+                  <a:tcPr>
+                    <a:solidFill>
+                      <a:srgbClr val="161C2D"/>
+                    </a:solidFill>
+                  </a:tcPr>
+                </a:tc>
+                <a:tc>
+                  <a:txBody>
+                    <a:bodyPr/>
+                    <a:lstStyle/>
+                    <a:p>
+                      <a:pPr algn="l"/>
+                      <a:r>
+                        <a:rPr sz="1200" b="1">
+                          <a:solidFill>
+                            <a:srgbClr val="6366F1"/>
+                          </a:solidFill>
+                          <a:latin typeface="Arial"/>
+                        </a:rPr>
+                        <a:t>Edge TTS &amp; Local Whisper Tiny</a:t>
+                      </a:r>
+                    </a:p>
+                  </a:txBody>
+                  <a:tcPr>
+                    <a:solidFill>
+                      <a:srgbClr val="161C2D"/>
+                    </a:solidFill>
+                  </a:tcPr>
+                </a:tc>
+                <a:tc>
+                  <a:txBody>
+                    <a:bodyPr/>
+                    <a:lstStyle/>
+                    <a:p>
+                      <a:pPr algn="l"/>
+                      <a:r>
+                        <a:rPr sz="1200">
+                          <a:solidFill>
+                            <a:srgbClr val="94A3B8"/>
+                          </a:solidFill>
+                          <a:latin typeface="Arial"/>
+                        </a:rPr>
+                        <a:t>Edge TTS synthesis provides natural neural voices for free; local Whisper transcription model runs locally in container with zero API rate limits.</a:t>
+                      </a:r>
+                    </a:p>
+                  </a:txBody>
+                  <a:tcPr>
+                    <a:solidFill>
+                      <a:srgbClr val="161C2D"/>
+                    </a:solidFill>
+                  </a:tcPr>
+                </a:tc>
+              </a:tr>
+            </a:tbl>
+          </a:graphicData>
+        </a:graphic>
+      </p:graphicFrame>
     </p:spTree>
   </p:cSld>
   <p:clrMapOvr>
@@ -4180,7 +4584,7 @@
             <a:avLst/>
           </a:prstGeom>
           <a:solidFill>
-            <a:srgbClr val="0F172A"/>
+            <a:srgbClr val="0B0F19"/>
           </a:solidFill>
           <a:ln>
             <a:noFill/>
@@ -4216,7 +4620,7 @@
         </p:nvSpPr>
         <p:spPr>
           <a:xfrm>
-            <a:off x="731520" y="457200"/>
+            <a:off x="731520" y="365760"/>
             <a:ext cx="10698480" cy="1097280"/>
           </a:xfrm>
           <a:prstGeom prst="rect">
@@ -4239,7 +4643,7 @@
               </a:defRPr>
             </a:pPr>
             <a:r>
-              <a:t>AI MOCK INTERVIEW PLATFORM</a:t>
+              <a:t>HACKATHON DELIVERABLE</a:t>
             </a:r>
           </a:p>
           <a:p>
@@ -4247,7 +4651,7 @@
               <a:spcBef>
                 <a:spcPts val="400"/>
               </a:spcBef>
-              <a:defRPr sz="2800" b="1">
+              <a:defRPr sz="2600" b="1">
                 <a:solidFill>
                   <a:srgbClr val="F8FAFC"/>
                 </a:solidFill>
@@ -4262,14 +4666,59 @@
       </p:sp>
       <p:sp>
         <p:nvSpPr>
-          <p:cNvPr id="4" name="TextBox 3"/>
-          <p:cNvSpPr txBox="1"/>
+          <p:cNvPr id="4" name="Rounded Rectangle 3"/>
+          <p:cNvSpPr/>
           <p:nvPr/>
         </p:nvSpPr>
         <p:spPr>
           <a:xfrm>
             <a:off x="731520" y="1645920"/>
-            <a:ext cx="10698480" cy="4572000"/>
+            <a:ext cx="3383280" cy="4389120"/>
+          </a:xfrm>
+          <a:prstGeom prst="roundRect">
+            <a:avLst/>
+          </a:prstGeom>
+          <a:solidFill>
+            <a:srgbClr val="161C2D"/>
+          </a:solidFill>
+          <a:ln w="19050">
+            <a:solidFill>
+              <a:srgbClr val="2DD4BF"/>
+            </a:solidFill>
+          </a:ln>
+        </p:spPr>
+        <p:style>
+          <a:lnRef idx="1">
+            <a:schemeClr val="accent1"/>
+          </a:lnRef>
+          <a:fillRef idx="3">
+            <a:schemeClr val="accent1"/>
+          </a:fillRef>
+          <a:effectRef idx="2">
+            <a:schemeClr val="accent1"/>
+          </a:effectRef>
+          <a:fontRef idx="minor">
+            <a:schemeClr val="lt1"/>
+          </a:fontRef>
+        </p:style>
+        <p:txBody>
+          <a:bodyPr rtlCol="0" anchor="ctr"/>
+          <a:lstStyle/>
+          <a:p>
+            <a:pPr algn="ctr"/>
+          </a:p>
+        </p:txBody>
+      </p:sp>
+      <p:sp>
+        <p:nvSpPr>
+          <p:cNvPr id="5" name="TextBox 4"/>
+          <p:cNvSpPr txBox="1"/>
+          <p:nvPr/>
+        </p:nvSpPr>
+        <p:spPr>
+          <a:xfrm>
+            <a:off x="914400" y="1828800"/>
+            <a:ext cx="3017520" cy="4023360"/>
           </a:xfrm>
           <a:prstGeom prst="rect">
             <a:avLst/>
@@ -4284,25 +4733,25 @@
           <a:p>
             <a:pPr>
               <a:spcAft>
-                <a:spcPts val="1800"/>
+                <a:spcPts val="1400"/>
               </a:spcAft>
-              <a:defRPr sz="1500">
-                <a:solidFill>
-                  <a:srgbClr val="F8FAFC"/>
+              <a:defRPr sz="1500" b="1">
+                <a:solidFill>
+                  <a:srgbClr val="2DD4BF"/>
                 </a:solidFill>
                 <a:latin typeface="Arial"/>
               </a:defRPr>
             </a:pPr>
             <a:r>
-              <a:t>Key upgrades implemented to ensure high stability during hackathon evaluations:</a:t>
+              <a:t>ROBUST PARSING CORE</a:t>
             </a:r>
           </a:p>
           <a:p>
             <a:pPr>
               <a:spcAft>
-                <a:spcPts val="1200"/>
+                <a:spcPts val="1000"/>
               </a:spcAft>
-              <a:defRPr sz="1400">
+              <a:defRPr sz="1200">
                 <a:solidFill>
                   <a:srgbClr val="94A3B8"/>
                 </a:solidFill>
@@ -4310,15 +4759,15 @@
               </a:defRPr>
             </a:pPr>
             <a:r>
-              <a:t>•  API Key Fallback Architecture: Primary LLM generation utilizes Google Gemini. If API rate limits (429) are encountered, the system automatically routes to Groq LLaMA-3.3-70B for zero downtime.</a:t>
+              <a:t>•  Multi-Format Reader: Handles PDF, DOCX, and TXT resume files natively.</a:t>
             </a:r>
           </a:p>
           <a:p>
             <a:pPr>
               <a:spcAft>
-                <a:spcPts val="1200"/>
+                <a:spcPts val="1000"/>
               </a:spcAft>
-              <a:defRPr sz="1400">
+              <a:defRPr sz="1200">
                 <a:solidFill>
                   <a:srgbClr val="94A3B8"/>
                 </a:solidFill>
@@ -4326,15 +4775,15 @@
               </a:defRPr>
             </a:pPr>
             <a:r>
-              <a:t>•  Dynamic Waveform Visualizer: Built HTML5 canvas scripts using Web Audio APIs (AnalyserNode) to draw real-time voice amplitude graphs as the candidate speaks.</a:t>
+              <a:t>•  Built-in DOCX Parser: Uses Python zipfile/XML structures to parse Word documents without external API dependancies.</a:t>
             </a:r>
           </a:p>
           <a:p>
             <a:pPr>
               <a:spcAft>
-                <a:spcPts val="1200"/>
+                <a:spcPts val="1000"/>
               </a:spcAft>
-              <a:defRPr sz="1400">
+              <a:defRPr sz="1200">
                 <a:solidFill>
                   <a:srgbClr val="94A3B8"/>
                 </a:solidFill>
@@ -4342,15 +4791,99 @@
               </a:defRPr>
             </a:pPr>
             <a:r>
-              <a:t>•  Advanced Parser (PDF, DOCX, TXT): Handles Word (.docx) documents natively using built-in Python XML parsing structures, eliminating external server dependencies.</a:t>
-            </a:r>
-          </a:p>
+              <a:t>•  SQLite Persistence: Saves profiles, sessions, and conversation history on-disk.</a:t>
+            </a:r>
+          </a:p>
+        </p:txBody>
+      </p:sp>
+      <p:sp>
+        <p:nvSpPr>
+          <p:cNvPr id="6" name="Rounded Rectangle 5"/>
+          <p:cNvSpPr/>
+          <p:nvPr/>
+        </p:nvSpPr>
+        <p:spPr>
+          <a:xfrm>
+            <a:off x="4389120" y="1645920"/>
+            <a:ext cx="3383280" cy="4389120"/>
+          </a:xfrm>
+          <a:prstGeom prst="roundRect">
+            <a:avLst/>
+          </a:prstGeom>
+          <a:solidFill>
+            <a:srgbClr val="161C2D"/>
+          </a:solidFill>
+          <a:ln w="19050">
+            <a:solidFill>
+              <a:srgbClr val="6366F1"/>
+            </a:solidFill>
+          </a:ln>
+        </p:spPr>
+        <p:style>
+          <a:lnRef idx="1">
+            <a:schemeClr val="accent1"/>
+          </a:lnRef>
+          <a:fillRef idx="3">
+            <a:schemeClr val="accent1"/>
+          </a:fillRef>
+          <a:effectRef idx="2">
+            <a:schemeClr val="accent1"/>
+          </a:effectRef>
+          <a:fontRef idx="minor">
+            <a:schemeClr val="lt1"/>
+          </a:fontRef>
+        </p:style>
+        <p:txBody>
+          <a:bodyPr rtlCol="0" anchor="ctr"/>
+          <a:lstStyle/>
+          <a:p>
+            <a:pPr algn="ctr"/>
+          </a:p>
+        </p:txBody>
+      </p:sp>
+      <p:sp>
+        <p:nvSpPr>
+          <p:cNvPr id="7" name="TextBox 6"/>
+          <p:cNvSpPr txBox="1"/>
+          <p:nvPr/>
+        </p:nvSpPr>
+        <p:spPr>
+          <a:xfrm>
+            <a:off x="4572000" y="1828800"/>
+            <a:ext cx="3017520" cy="4023360"/>
+          </a:xfrm>
+          <a:prstGeom prst="rect">
+            <a:avLst/>
+          </a:prstGeom>
+          <a:noFill/>
+        </p:spPr>
+        <p:txBody>
+          <a:bodyPr wrap="square" lIns="0" tIns="0" rIns="0" bIns="0">
+            <a:spAutoFit/>
+          </a:bodyPr>
+          <a:lstStyle/>
           <a:p>
             <a:pPr>
               <a:spcAft>
-                <a:spcPts val="1200"/>
+                <a:spcPts val="1400"/>
               </a:spcAft>
-              <a:defRPr sz="1400">
+              <a:defRPr sz="1500" b="1">
+                <a:solidFill>
+                  <a:srgbClr val="6366F1"/>
+                </a:solidFill>
+                <a:latin typeface="Arial"/>
+              </a:defRPr>
+            </a:pPr>
+            <a:r>
+              <a:t>UI ENHANCEMENTS</a:t>
+            </a:r>
+          </a:p>
+          <a:p>
+            <a:pPr>
+              <a:spcAft>
+                <a:spcPts val="1000"/>
+              </a:spcAft>
+              <a:defRPr sz="1200">
                 <a:solidFill>
                   <a:srgbClr val="94A3B8"/>
                 </a:solidFill>
@@ -4358,15 +4891,15 @@
               </a:defRPr>
             </a:pPr>
             <a:r>
-              <a:t>•  Robust JSON Extraction: Uses regex isolation loops to capture JSON bounds ({ and }), preventing LLM conversation text from breaking data frames.</a:t>
+              <a:t>•  Canvas Waveform Visualizer: Dynamic waveform charts drawn in browser via custom Streamlit Javascript components.</a:t>
             </a:r>
           </a:p>
           <a:p>
             <a:pPr>
               <a:spcAft>
-                <a:spcPts val="1200"/>
+                <a:spcPts val="1000"/>
               </a:spcAft>
-              <a:defRPr sz="1400">
+              <a:defRPr sz="1200">
                 <a:solidFill>
                   <a:srgbClr val="94A3B8"/>
                 </a:solidFill>
@@ -4374,7 +4907,155 @@
               </a:defRPr>
             </a:pPr>
             <a:r>
-              <a:t>•  Secure Deployment: Docker container runs under non-root user permissions (UID 1000) with Nginx temp folders and logs explicitly configured under /tmp/.</a:t>
+              <a:t>•  Matplotlib Breakdown Charts: Headless canvas drawing translates scoring arrays into bar visuals.</a:t>
+            </a:r>
+          </a:p>
+          <a:p>
+            <a:pPr>
+              <a:spcAft>
+                <a:spcPts val="1000"/>
+              </a:spcAft>
+              <a:defRPr sz="1200">
+                <a:solidFill>
+                  <a:srgbClr val="94A3B8"/>
+                </a:solidFill>
+                <a:latin typeface="Arial"/>
+              </a:defRPr>
+            </a:pPr>
+            <a:r>
+              <a:t>•  Detailed Error Outputs: Feeds raw API failure strings directly to UI for diagnostic clarity.</a:t>
+            </a:r>
+          </a:p>
+        </p:txBody>
+      </p:sp>
+      <p:sp>
+        <p:nvSpPr>
+          <p:cNvPr id="8" name="Rounded Rectangle 7"/>
+          <p:cNvSpPr/>
+          <p:nvPr/>
+        </p:nvSpPr>
+        <p:spPr>
+          <a:xfrm>
+            <a:off x="8046720" y="1645920"/>
+            <a:ext cx="3383280" cy="4389120"/>
+          </a:xfrm>
+          <a:prstGeom prst="roundRect">
+            <a:avLst/>
+          </a:prstGeom>
+          <a:solidFill>
+            <a:srgbClr val="161C2D"/>
+          </a:solidFill>
+          <a:ln w="19050">
+            <a:solidFill>
+              <a:srgbClr val="EF4444"/>
+            </a:solidFill>
+          </a:ln>
+        </p:spPr>
+        <p:style>
+          <a:lnRef idx="1">
+            <a:schemeClr val="accent1"/>
+          </a:lnRef>
+          <a:fillRef idx="3">
+            <a:schemeClr val="accent1"/>
+          </a:fillRef>
+          <a:effectRef idx="2">
+            <a:schemeClr val="accent1"/>
+          </a:effectRef>
+          <a:fontRef idx="minor">
+            <a:schemeClr val="lt1"/>
+          </a:fontRef>
+        </p:style>
+        <p:txBody>
+          <a:bodyPr rtlCol="0" anchor="ctr"/>
+          <a:lstStyle/>
+          <a:p>
+            <a:pPr algn="ctr"/>
+          </a:p>
+        </p:txBody>
+      </p:sp>
+      <p:sp>
+        <p:nvSpPr>
+          <p:cNvPr id="9" name="TextBox 8"/>
+          <p:cNvSpPr txBox="1"/>
+          <p:nvPr/>
+        </p:nvSpPr>
+        <p:spPr>
+          <a:xfrm>
+            <a:off x="8229600" y="1828800"/>
+            <a:ext cx="3017520" cy="4023360"/>
+          </a:xfrm>
+          <a:prstGeom prst="rect">
+            <a:avLst/>
+          </a:prstGeom>
+          <a:noFill/>
+        </p:spPr>
+        <p:txBody>
+          <a:bodyPr wrap="square" lIns="0" tIns="0" rIns="0" bIns="0">
+            <a:spAutoFit/>
+          </a:bodyPr>
+          <a:lstStyle/>
+          <a:p>
+            <a:pPr>
+              <a:spcAft>
+                <a:spcPts val="1400"/>
+              </a:spcAft>
+              <a:defRPr sz="1500" b="1">
+                <a:solidFill>
+                  <a:srgbClr val="EF4444"/>
+                </a:solidFill>
+                <a:latin typeface="Arial"/>
+              </a:defRPr>
+            </a:pPr>
+            <a:r>
+              <a:t>FAILOVER RESILIENCY</a:t>
+            </a:r>
+          </a:p>
+          <a:p>
+            <a:pPr>
+              <a:spcAft>
+                <a:spcPts val="1000"/>
+              </a:spcAft>
+              <a:defRPr sz="1200">
+                <a:solidFill>
+                  <a:srgbClr val="94A3B8"/>
+                </a:solidFill>
+                <a:latin typeface="Arial"/>
+              </a:defRPr>
+            </a:pPr>
+            <a:r>
+              <a:t>•  Gemini-to-Groq Failovers: Switches automatically to Groq LLaMA-3.3-70B if Gemini triggers rate-limit (429) errors.</a:t>
+            </a:r>
+          </a:p>
+          <a:p>
+            <a:pPr>
+              <a:spcAft>
+                <a:spcPts val="1000"/>
+              </a:spcAft>
+              <a:defRPr sz="1200">
+                <a:solidFill>
+                  <a:srgbClr val="94A3B8"/>
+                </a:solidFill>
+                <a:latin typeface="Arial"/>
+              </a:defRPr>
+            </a:pPr>
+            <a:r>
+              <a:t>•  JSON Boundary Cleaners: Regex boundary isolators parse structured outputs reliably.</a:t>
+            </a:r>
+          </a:p>
+          <a:p>
+            <a:pPr>
+              <a:spcAft>
+                <a:spcPts val="1000"/>
+              </a:spcAft>
+              <a:defRPr sz="1200">
+                <a:solidFill>
+                  <a:srgbClr val="94A3B8"/>
+                </a:solidFill>
+                <a:latin typeface="Arial"/>
+              </a:defRPr>
+            </a:pPr>
+            <a:r>
+              <a:t>•  Secure Docker Settings: Runs under non-root UID 1000 with Nginx folders mapped to /tmp.</a:t>
             </a:r>
           </a:p>
         </p:txBody>
@@ -4412,7 +5093,7 @@
             <a:avLst/>
           </a:prstGeom>
           <a:solidFill>
-            <a:srgbClr val="0F172A"/>
+            <a:srgbClr val="0B0F19"/>
           </a:solidFill>
           <a:ln>
             <a:noFill/>
@@ -4448,7 +5129,7 @@
         </p:nvSpPr>
         <p:spPr>
           <a:xfrm>
-            <a:off x="731520" y="457200"/>
+            <a:off x="731520" y="365760"/>
             <a:ext cx="10698480" cy="1097280"/>
           </a:xfrm>
           <a:prstGeom prst="rect">
@@ -4471,7 +5152,7 @@
               </a:defRPr>
             </a:pPr>
             <a:r>
-              <a:t>AI MOCK INTERVIEW PLATFORM</a:t>
+              <a:t>HACKATHON DELIVERABLE</a:t>
             </a:r>
           </a:p>
           <a:p>
@@ -4479,7 +5160,7 @@
               <a:spcBef>
                 <a:spcPts val="400"/>
               </a:spcBef>
-              <a:defRPr sz="2800" b="1">
+              <a:defRPr sz="2600" b="1">
                 <a:solidFill>
                   <a:srgbClr val="F8FAFC"/>
                 </a:solidFill>
@@ -4494,14 +5175,59 @@
       </p:sp>
       <p:sp>
         <p:nvSpPr>
-          <p:cNvPr id="4" name="TextBox 3"/>
+          <p:cNvPr id="4" name="Rounded Rectangle 3"/>
+          <p:cNvSpPr/>
+          <p:nvPr/>
+        </p:nvSpPr>
+        <p:spPr>
+          <a:xfrm>
+            <a:off x="731520" y="1828800"/>
+            <a:ext cx="5120640" cy="1828800"/>
+          </a:xfrm>
+          <a:prstGeom prst="roundRect">
+            <a:avLst/>
+          </a:prstGeom>
+          <a:solidFill>
+            <a:srgbClr val="161C2D"/>
+          </a:solidFill>
+          <a:ln w="19050">
+            <a:solidFill>
+              <a:srgbClr val="2DD4BF"/>
+            </a:solidFill>
+          </a:ln>
+        </p:spPr>
+        <p:style>
+          <a:lnRef idx="1">
+            <a:schemeClr val="accent1"/>
+          </a:lnRef>
+          <a:fillRef idx="3">
+            <a:schemeClr val="accent1"/>
+          </a:fillRef>
+          <a:effectRef idx="2">
+            <a:schemeClr val="accent1"/>
+          </a:effectRef>
+          <a:fontRef idx="minor">
+            <a:schemeClr val="lt1"/>
+          </a:fontRef>
+        </p:style>
+        <p:txBody>
+          <a:bodyPr rtlCol="0" anchor="ctr"/>
+          <a:lstStyle/>
+          <a:p>
+            <a:pPr algn="ctr"/>
+          </a:p>
+        </p:txBody>
+      </p:sp>
+      <p:sp>
+        <p:nvSpPr>
+          <p:cNvPr id="5" name="TextBox 4"/>
           <p:cNvSpPr txBox="1"/>
           <p:nvPr/>
         </p:nvSpPr>
         <p:spPr>
           <a:xfrm>
-            <a:off x="731520" y="1645920"/>
-            <a:ext cx="10698480" cy="4572000"/>
+            <a:off x="914400" y="2011680"/>
+            <a:ext cx="4754880" cy="1463040"/>
           </a:xfrm>
           <a:prstGeom prst="rect">
             <a:avLst/>
@@ -4509,112 +5235,399 @@
           <a:noFill/>
         </p:spPr>
         <p:txBody>
-          <a:bodyPr wrap="square" lIns="0" tIns="0" rIns="0" bIns="0">
+          <a:bodyPr wrap="square">
             <a:spAutoFit/>
           </a:bodyPr>
           <a:lstStyle/>
           <a:p>
             <a:pPr>
+              <a:defRPr sz="1100" b="1">
+                <a:solidFill>
+                  <a:srgbClr val="2DD4BF"/>
+                </a:solidFill>
+                <a:latin typeface="Arial"/>
+              </a:defRPr>
+            </a:pPr>
+            <a:r>
+              <a:t>LIVE DEPLOYMENT</a:t>
+            </a:r>
+          </a:p>
+          <a:p>
+            <a:pPr>
+              <a:spcBef>
+                <a:spcPts val="800"/>
+              </a:spcBef>
+            </a:pPr>
+            <a:r>
+              <a:rPr sz="1400" b="1" u="sng">
+                <a:solidFill>
+                  <a:srgbClr val="F8FAFC"/>
+                </a:solidFill>
+                <a:latin typeface="Arial"/>
+                <a:hlinkClick r:id="rId2"/>
+              </a:rPr>
+              <a:t>👉 CLICK HERE TO OPEN HUGGING FACE SPACE</a:t>
+            </a:r>
+          </a:p>
+          <a:p>
+            <a:pPr>
+              <a:spcBef>
+                <a:spcPts val="400"/>
+              </a:spcBef>
+              <a:defRPr sz="1100">
+                <a:solidFill>
+                  <a:srgbClr val="94A3B8"/>
+                </a:solidFill>
+                <a:latin typeface="Arial"/>
+              </a:defRPr>
+            </a:pPr>
+            <a:r>
+              <a:t>Runs on CPU Basic tier with secure Nginx routing and Supervisord management.</a:t>
+            </a:r>
+          </a:p>
+        </p:txBody>
+      </p:sp>
+      <p:sp>
+        <p:nvSpPr>
+          <p:cNvPr id="6" name="Rounded Rectangle 5"/>
+          <p:cNvSpPr/>
+          <p:nvPr/>
+        </p:nvSpPr>
+        <p:spPr>
+          <a:xfrm>
+            <a:off x="731520" y="4114800"/>
+            <a:ext cx="5120640" cy="1828800"/>
+          </a:xfrm>
+          <a:prstGeom prst="roundRect">
+            <a:avLst/>
+          </a:prstGeom>
+          <a:solidFill>
+            <a:srgbClr val="161C2D"/>
+          </a:solidFill>
+          <a:ln w="19050">
+            <a:solidFill>
+              <a:srgbClr val="6366F1"/>
+            </a:solidFill>
+          </a:ln>
+        </p:spPr>
+        <p:style>
+          <a:lnRef idx="1">
+            <a:schemeClr val="accent1"/>
+          </a:lnRef>
+          <a:fillRef idx="3">
+            <a:schemeClr val="accent1"/>
+          </a:fillRef>
+          <a:effectRef idx="2">
+            <a:schemeClr val="accent1"/>
+          </a:effectRef>
+          <a:fontRef idx="minor">
+            <a:schemeClr val="lt1"/>
+          </a:fontRef>
+        </p:style>
+        <p:txBody>
+          <a:bodyPr rtlCol="0" anchor="ctr"/>
+          <a:lstStyle/>
+          <a:p>
+            <a:pPr algn="ctr"/>
+          </a:p>
+        </p:txBody>
+      </p:sp>
+      <p:sp>
+        <p:nvSpPr>
+          <p:cNvPr id="7" name="TextBox 6"/>
+          <p:cNvSpPr txBox="1"/>
+          <p:nvPr/>
+        </p:nvSpPr>
+        <p:spPr>
+          <a:xfrm>
+            <a:off x="914400" y="4297680"/>
+            <a:ext cx="4754880" cy="1463040"/>
+          </a:xfrm>
+          <a:prstGeom prst="rect">
+            <a:avLst/>
+          </a:prstGeom>
+          <a:noFill/>
+        </p:spPr>
+        <p:txBody>
+          <a:bodyPr wrap="square">
+            <a:spAutoFit/>
+          </a:bodyPr>
+          <a:lstStyle/>
+          <a:p>
+            <a:pPr>
+              <a:defRPr sz="1100" b="1">
+                <a:solidFill>
+                  <a:srgbClr val="6366F1"/>
+                </a:solidFill>
+                <a:latin typeface="Arial"/>
+              </a:defRPr>
+            </a:pPr>
+            <a:r>
+              <a:t>GITHUB REPOSITORY</a:t>
+            </a:r>
+          </a:p>
+          <a:p>
+            <a:pPr>
+              <a:spcBef>
+                <a:spcPts val="800"/>
+              </a:spcBef>
+            </a:pPr>
+            <a:r>
+              <a:rPr sz="1400" b="1" u="sng">
+                <a:solidFill>
+                  <a:srgbClr val="F8FAFC"/>
+                </a:solidFill>
+                <a:latin typeface="Arial"/>
+                <a:hlinkClick r:id="rId3"/>
+              </a:rPr>
+              <a:t>👉 CLICK HERE TO VIEW CODE ON GITHUB</a:t>
+            </a:r>
+          </a:p>
+          <a:p>
+            <a:pPr>
+              <a:spcBef>
+                <a:spcPts val="400"/>
+              </a:spcBef>
+              <a:defRPr sz="1100">
+                <a:solidFill>
+                  <a:srgbClr val="94A3B8"/>
+                </a:solidFill>
+                <a:latin typeface="Arial"/>
+              </a:defRPr>
+            </a:pPr>
+            <a:r>
+              <a:t>Fully open source repository containing pipeline tests and actions workflow.</a:t>
+            </a:r>
+          </a:p>
+        </p:txBody>
+      </p:sp>
+      <p:sp>
+        <p:nvSpPr>
+          <p:cNvPr id="8" name="Rounded Rectangle 7"/>
+          <p:cNvSpPr/>
+          <p:nvPr/>
+        </p:nvSpPr>
+        <p:spPr>
+          <a:xfrm>
+            <a:off x="6309360" y="1828800"/>
+            <a:ext cx="5120640" cy="4114800"/>
+          </a:xfrm>
+          <a:prstGeom prst="roundRect">
+            <a:avLst/>
+          </a:prstGeom>
+          <a:solidFill>
+            <a:srgbClr val="0A0F1E"/>
+          </a:solidFill>
+          <a:ln w="19050">
+            <a:solidFill>
+              <a:srgbClr val="6366F1"/>
+            </a:solidFill>
+          </a:ln>
+        </p:spPr>
+        <p:style>
+          <a:lnRef idx="1">
+            <a:schemeClr val="accent1"/>
+          </a:lnRef>
+          <a:fillRef idx="3">
+            <a:schemeClr val="accent1"/>
+          </a:fillRef>
+          <a:effectRef idx="2">
+            <a:schemeClr val="accent1"/>
+          </a:effectRef>
+          <a:fontRef idx="minor">
+            <a:schemeClr val="lt1"/>
+          </a:fontRef>
+        </p:style>
+        <p:txBody>
+          <a:bodyPr rtlCol="0" anchor="ctr"/>
+          <a:lstStyle/>
+          <a:p>
+            <a:pPr algn="ctr"/>
+          </a:p>
+        </p:txBody>
+      </p:sp>
+      <p:sp>
+        <p:nvSpPr>
+          <p:cNvPr id="9" name="TextBox 8"/>
+          <p:cNvSpPr txBox="1"/>
+          <p:nvPr/>
+        </p:nvSpPr>
+        <p:spPr>
+          <a:xfrm>
+            <a:off x="6492240" y="2011680"/>
+            <a:ext cx="4754880" cy="3749039"/>
+          </a:xfrm>
+          <a:prstGeom prst="rect">
+            <a:avLst/>
+          </a:prstGeom>
+          <a:noFill/>
+        </p:spPr>
+        <p:txBody>
+          <a:bodyPr wrap="square">
+            <a:spAutoFit/>
+          </a:bodyPr>
+          <a:lstStyle/>
+          <a:p>
+            <a:pPr>
               <a:spcAft>
-                <a:spcPts val="1800"/>
+                <a:spcPts val="1400"/>
               </a:spcAft>
-              <a:defRPr sz="1600" b="1">
+              <a:defRPr sz="1300" b="1">
+                <a:solidFill>
+                  <a:srgbClr val="6366F1"/>
+                </a:solidFill>
+                <a:latin typeface="Arial"/>
+              </a:defRPr>
+            </a:pPr>
+            <a:r>
+              <a:t>LOCAL RUN INSTRUCTIONS (TERMINAL)</a:t>
+            </a:r>
+          </a:p>
+          <a:p>
+            <a:pPr>
+              <a:defRPr sz="1000">
                 <a:solidFill>
                   <a:srgbClr val="2DD4BF"/>
                 </a:solidFill>
-                <a:latin typeface="Arial"/>
-              </a:defRPr>
-            </a:pPr>
-            <a:r>
-              <a:t>Live Deployment Space &amp; Repository Details:</a:t>
-            </a:r>
-          </a:p>
-          <a:p>
-            <a:pPr>
-              <a:spcAft>
-                <a:spcPts val="1200"/>
-              </a:spcAft>
-              <a:defRPr sz="1400">
+                <a:latin typeface="Courier New"/>
+              </a:defRPr>
+            </a:pPr>
+            <a:r>
+              <a:t># Clone the Repository</a:t>
+            </a:r>
+          </a:p>
+          <a:p>
+            <a:pPr>
+              <a:defRPr sz="1000">
                 <a:solidFill>
                   <a:srgbClr val="F8FAFC"/>
                 </a:solidFill>
-                <a:latin typeface="Arial"/>
-              </a:defRPr>
-            </a:pPr>
-            <a:r>
-              <a:t>•  HUGGING FACE DEPLOYMENT: https://huggingface.co/spaces/tejashrichoudhary2/AI-Mock-Interview-Platform</a:t>
-            </a:r>
-          </a:p>
-          <a:p>
-            <a:pPr>
-              <a:spcAft>
-                <a:spcPts val="1200"/>
-              </a:spcAft>
-              <a:defRPr sz="1400">
+                <a:latin typeface="Courier New"/>
+              </a:defRPr>
+            </a:pPr>
+            <a:r>
+              <a:t>git clone https://github.com/tejashri-del098/AI-Mock-Interview-Platform.git</a:t>
+            </a:r>
+          </a:p>
+          <a:p>
+            <a:pPr>
+              <a:defRPr sz="1000">
                 <a:solidFill>
                   <a:srgbClr val="F8FAFC"/>
                 </a:solidFill>
-                <a:latin typeface="Arial"/>
-              </a:defRPr>
-            </a:pPr>
-            <a:r>
-              <a:t>•  GITHUB REPOSITORY: https://github.com/tejashri-del098/AI-Mock-Interview-Platform</a:t>
-            </a:r>
-          </a:p>
-          <a:p>
-            <a:pPr>
-              <a:spcAft>
-                <a:spcPts val="1200"/>
-              </a:spcAft>
-              <a:defRPr sz="1400">
+                <a:latin typeface="Courier New"/>
+              </a:defRPr>
+            </a:pPr>
+            <a:r>
+              <a:t>cd AI-Mock-Interview-Platform</a:t>
+            </a:r>
+          </a:p>
+          <a:p>
+            <a:pPr>
+              <a:defRPr sz="1000">
                 <a:solidFill>
                   <a:srgbClr val="F8FAFC"/>
                 </a:solidFill>
-                <a:latin typeface="Arial"/>
-              </a:defRPr>
-            </a:pPr>
-            <a:r>
-              <a:t>•  CI/CD AUTOMATION: Built GitHub Actions pipeline (.github/workflows/deploy.yml) that syncs code triggers automatically.</a:t>
-            </a:r>
-          </a:p>
-          <a:p>
-            <a:pPr>
-              <a:spcAft>
-                <a:spcPts val="1200"/>
-              </a:spcAft>
-              <a:defRPr sz="1400">
+                <a:latin typeface="Courier New"/>
+              </a:defRPr>
+            </a:pPr>
+          </a:p>
+          <a:p>
+            <a:pPr>
+              <a:defRPr sz="1000">
+                <a:solidFill>
+                  <a:srgbClr val="2DD4BF"/>
+                </a:solidFill>
+                <a:latin typeface="Courier New"/>
+              </a:defRPr>
+            </a:pPr>
+            <a:r>
+              <a:t># Install dependencies</a:t>
+            </a:r>
+          </a:p>
+          <a:p>
+            <a:pPr>
+              <a:defRPr sz="1000">
                 <a:solidFill>
                   <a:srgbClr val="F8FAFC"/>
                 </a:solidFill>
-                <a:latin typeface="Arial"/>
-              </a:defRPr>
-            </a:pPr>
-            <a:r>
-              <a:t>•  DOCKER ORCHESTRATION: Full multi-process config packaged cleanly with custom Dockerfile, Nginx proxy, and Supervisor.</a:t>
-            </a:r>
-          </a:p>
-          <a:p>
-            <a:pPr>
-              <a:spcAft>
-                <a:spcPts val="1200"/>
-              </a:spcAft>
-              <a:defRPr sz="1400">
+                <a:latin typeface="Courier New"/>
+              </a:defRPr>
+            </a:pPr>
+            <a:r>
+              <a:t>pip install -r requirements.txt</a:t>
+            </a:r>
+          </a:p>
+          <a:p>
+            <a:pPr>
+              <a:defRPr sz="1000">
                 <a:solidFill>
                   <a:srgbClr val="F8FAFC"/>
                 </a:solidFill>
-                <a:latin typeface="Arial"/>
-              </a:defRPr>
-            </a:pPr>
-            <a:r>
-              <a:t>•  LOCAL TESTING COMMANDS:</a:t>
-            </a:r>
-            <a:br/>
-            <a:r>
-              <a:t>   - Terminal 1 (Backend): uvicorn app.api.main:app --reload --port 8000</a:t>
-            </a:r>
-            <a:br/>
-            <a:r>
-              <a:t>   - Terminal 2 (Frontend): streamlit run app/ui/app.py</a:t>
+                <a:latin typeface="Courier New"/>
+              </a:defRPr>
+            </a:pPr>
+          </a:p>
+          <a:p>
+            <a:pPr>
+              <a:defRPr sz="1000">
+                <a:solidFill>
+                  <a:srgbClr val="2DD4BF"/>
+                </a:solidFill>
+                <a:latin typeface="Courier New"/>
+              </a:defRPr>
+            </a:pPr>
+            <a:r>
+              <a:t># Run FastAPI Backend Server (Terminal 1)</a:t>
+            </a:r>
+          </a:p>
+          <a:p>
+            <a:pPr>
+              <a:defRPr sz="1000">
+                <a:solidFill>
+                  <a:srgbClr val="F8FAFC"/>
+                </a:solidFill>
+                <a:latin typeface="Courier New"/>
+              </a:defRPr>
+            </a:pPr>
+            <a:r>
+              <a:t>uvicorn app.api.main:app --reload --port 8000</a:t>
+            </a:r>
+          </a:p>
+          <a:p>
+            <a:pPr>
+              <a:defRPr sz="1000">
+                <a:solidFill>
+                  <a:srgbClr val="F8FAFC"/>
+                </a:solidFill>
+                <a:latin typeface="Courier New"/>
+              </a:defRPr>
+            </a:pPr>
+          </a:p>
+          <a:p>
+            <a:pPr>
+              <a:defRPr sz="1000">
+                <a:solidFill>
+                  <a:srgbClr val="2DD4BF"/>
+                </a:solidFill>
+                <a:latin typeface="Courier New"/>
+              </a:defRPr>
+            </a:pPr>
+            <a:r>
+              <a:t># Run Streamlit Frontend dashboard (Terminal 2)</a:t>
+            </a:r>
+          </a:p>
+          <a:p>
+            <a:pPr>
+              <a:defRPr sz="1000">
+                <a:solidFill>
+                  <a:srgbClr val="F8FAFC"/>
+                </a:solidFill>
+                <a:latin typeface="Courier New"/>
+              </a:defRPr>
+            </a:pPr>
+            <a:r>
+              <a:t>streamlit run app/ui/app.py</a:t>
             </a:r>
           </a:p>
         </p:txBody>

</xml_diff>